<commit_message>
docs: update recording slides for file city and current evidence
</commit_message>
<xml_diff>
--- a/docs/CoreSpace-Recording.pptx
+++ b/docs/CoreSpace-Recording.pptx
@@ -536,7 +536,7 @@
           <a:p/>
           <a:p>
             <a:r>
-              <a:t>หลักฐาน: docs/results/REAL_SCANNER_INTEGRATION.md; โค้ด: scanner/diskviz-scan.c, backend/scan_manager.py, backend/allocated_size.py</a:t>
+              <a:t>หลักฐาน: docs/results/UX_CITY_UAT.md; docs/results/READABLE_FILES_FIX.md; docs/results/REAL_SCANNER_INTEGRATION.md</a:t>
             </a:r>
           </a:p>
         </p:txBody>
@@ -606,7 +606,7 @@
           <a:lstStyle/>
           <a:p>
             <a:r>
-              <a:t>OS ช่วยให้เรารู้ว่าโฟลเดอร์ใดใช้พื้นที่มาก</a:t>
+              <a:t>OS ช่วยให้เรารู้ว่าไฟล์ใดใช้พื้นที่มาก</a:t>
             </a:r>
           </a:p>
           <a:p/>
@@ -618,13 +618,13 @@
           <a:p/>
           <a:p>
             <a:r>
-              <a:t>เมื่อมีไฟล์กระจายหลายโฟลเดอร์ เราอาจไม่รู้ว่าอะไรใช้พื้นที่มาก งานนี้ให้เลือกโฟลเดอร์แล้วดูโครงสร้างและขนาดได้ครับ ตัวข้อมูลมาจากระบบปฏิบัติการ กราฟแท่งเปรียบเทียบขนาด Allocated สีเขียวคือโฟลเดอร์ สีน้ำเงินคือไฟล์ กดชื่อโฟลเดอร์เพื่อดูข้างในได้ ภาพนี้เป็นผล C และ Python จริงบน Windows แล้ว ต่อไปศรัณย์จะอธิบายว่าเราอ่านข้อมูลนั้นได้อย่างไรครับ</a:t>
+              <a:t>เมื่อไฟล์กระจายหลายโฟลเดอร์ เราอาจไม่รู้ว่าอะไรใช้พื้นที่มาก CoreSpace แปลงข้อมูลที่ OS อ่านได้เป็นเมืองไฟล์ครับ พื้นที่ฐานอาคารใช้เทียบสัดส่วนขนาดในมุมมองนี้ เลือกอาคารแล้วชื่อและขนาดค้างอยู่ด้านข้าง ถ้าไฟล์เล็กจนหาไม่เจอ สามารถค้นจากผลสแกนทั้งหมดได้ ภาพนี้มาจาก C และ Python อ่านไฟล์จริงในโปรเจกต์บน Windows ต่อไปศรัณย์จะอธิบายว่าเราอ่านข้อมูลนั้นได้อย่างไรครับ</a:t>
             </a:r>
           </a:p>
           <a:p/>
           <a:p>
             <a:r>
-              <a:t>ชี้กราฟจริงว่า many ประมาณ 64.1% และ large.bin ประมาณ 35.9% ของยอดโฟลเดอร์ที่อ่านได้ ความยาวแท่งเทียบกับรายการใหญ่ที่สุด ไม่ใช่เปอร์เซ็นต์ความจุไดรฟ์ ไม่แจกแจงทุกปุ่ม</a:t>
+              <a:t>ชี้พื้นที่ฐาน ไม่ใช้ความสูงอาคารเป็นสเกลไบต์โดยตรง เพราะความสูงใช้ log หน้าต่างเป็นการตกแต่ง ไม่ใช่จำนวนไฟล์ สีใช้ช่วยแยกประเภทตามนามสกุล ดูชื่อประกอบได้ รายการที่เป็นศูนย์หรือไม่ทราบขนาดยังแสดงในส่วนแยก ไม่สมมติพื้นที่ให้มัน</a:t>
             </a:r>
           </a:p>
           <a:p/>
@@ -632,7 +632,7 @@
           <a:p/>
           <a:p>
             <a:r>
-              <a:t>หลักฐาน: docs/results/REAL_SCANNER_INTEGRATION.md; โค้ด: scanner/diskviz-scan.c, backend/scan_manager.py, backend/allocated_size.py</a:t>
+              <a:t>หลักฐาน: docs/results/UX_CITY_UAT.md; docs/results/READABLE_FILES_FIX.md; docs/results/REAL_SCANNER_INTEGRATION.md</a:t>
             </a:r>
           </a:p>
         </p:txBody>
@@ -728,7 +728,7 @@
           <a:p/>
           <a:p>
             <a:r>
-              <a:t>หลักฐาน: docs/results/REAL_SCANNER_INTEGRATION.md; โค้ด: scanner/diskviz-scan.c, backend/scan_manager.py, backend/allocated_size.py</a:t>
+              <a:t>หลักฐาน: docs/results/UX_CITY_UAT.md; docs/results/READABLE_FILES_FIX.md; docs/results/REAL_SCANNER_INTEGRATION.md</a:t>
             </a:r>
           </a:p>
         </p:txBody>
@@ -830,7 +830,7 @@
           <a:p/>
           <a:p>
             <a:r>
-              <a:t>หลักฐาน: docs/results/REAL_SCANNER_INTEGRATION.md; โค้ด: scanner/diskviz-scan.c, backend/scan_manager.py, backend/allocated_size.py</a:t>
+              <a:t>หลักฐาน: docs/results/UX_CITY_UAT.md; docs/results/READABLE_FILES_FIX.md; docs/results/REAL_SCANNER_INTEGRATION.md</a:t>
             </a:r>
           </a:p>
         </p:txBody>
@@ -932,7 +932,7 @@
           <a:p/>
           <a:p>
             <a:r>
-              <a:t>หลักฐาน: docs/results/REAL_SCANNER_INTEGRATION.md; โค้ด: scanner/diskviz-scan.c, backend/scan_manager.py, backend/allocated_size.py</a:t>
+              <a:t>หลักฐาน: docs/results/UX_CITY_UAT.md; docs/results/READABLE_FILES_FIX.md; docs/results/REAL_SCANNER_INTEGRATION.md</a:t>
             </a:r>
           </a:p>
         </p:txBody>
@@ -1034,7 +1034,7 @@
           <a:p/>
           <a:p>
             <a:r>
-              <a:t>หลักฐาน: docs/results/REAL_SCANNER_INTEGRATION.md; โค้ด: scanner/diskviz-scan.c, backend/scan_manager.py, backend/allocated_size.py</a:t>
+              <a:t>หลักฐาน: docs/results/UX_CITY_UAT.md; docs/results/READABLE_FILES_FIX.md; docs/results/REAL_SCANNER_INTEGRATION.md</a:t>
             </a:r>
           </a:p>
         </p:txBody>
@@ -1116,13 +1116,13 @@
           <a:p/>
           <a:p>
             <a:r>
-              <a:t>เปิดเว็บปกติที่ `http://127.0.0.1:8080` ไม่ใช้ `/?mock=1` ก่อนอัดต้องเปิดเซิร์ฟเวอร์และตั้ง C แล้ว ใช้ fixture ที่สร้างด้วย `tools/prepare_demo_fixture.ps1 -Target &lt;โฟลเดอร์ใหม่&gt; -VariedSizes` เตรียมอีกชุดด้วย `-IncludeJunction` และสแกนเก็บไว้ก่อน อัดเฉพาะหน้าต่างเว็บพร้อมเสียงอธิบาย</a:t>
+              <a:t>เปิดเว็บปกติ `http://127.0.0.1:8080` ตั้ง C ใน WSL ก่อนอัด ใช้โฟลเดอร์ไฟล์จริงที่เตรียมด้วย `prepare_demo_fixture.ps1 -VariedSizes` และเตรียมผลที่มี junction ไว้ก่อน อัดเฉพาะเว็บพร้อมเสียง</a:t>
             </a:r>
           </a:p>
           <a:p/>
           <a:p>
             <a:r>
-              <a:t>| เวลา | สิ่งที่ทำ | คำอธิบาย OS ที่พูด |</a:t>
+              <a:t>| เวลา | สิ่งที่ทำ | คำอธิบาย OS |</a:t>
             </a:r>
           </a:p>
           <a:p>
@@ -1132,46 +1132,39 @@
           </a:p>
           <a:p>
             <a:r>
-              <a:t>| 00:00–00:30 | เลือก fixture ปกติแล้วกด Scan ดูจำนวนและสถานะ | Python เริ่ม process C และเว็บติดตามงานเบื้องหลัง ขนาดยังไม่ทราบจนได้รับข้อมูล |</a:t>
-            </a:r>
-          </a:p>
-          <a:p>
-            <a:r>
-              <a:t>| 00:30–01:00 | ชี้กราฟ many กับ large.bin กดโฟลเดอร์จากกราฟ ดูกราฟลูก แล้วแสดงเพิ่มเติมจาก 50 จนได้ 60 กาง tree สั้น ๆ | ขนาดมาจาก metadata/Windows API กราฟใช้รายการที่โหลดแล้ว เว็บไม่ต้องโหลดทั้งไดรฟ์ |</a:t>
-            </a:r>
-          </a:p>
-          <a:p>
-            <a:r>
-              <a:t>| 01:00–01:25 | กลับ root ดู zero.bin กับ large.bin และกด Reveal หนึ่งครั้ง | แยก metadata/ขนาดสองค่า และการเปิดตำแหน่งจากผลสแกน |</a:t>
-            </a:r>
-          </a:p>
-          <a:p>
-            <a:r>
-              <a:t>| 01:25–02:00 | เปิดผล fixture junction จริงที่เตรียมไว้ แล้วเปิด “ดูเหตุผลที่ข้อมูลไม่ครบ” | OS มีรายการชนิดลิงก์ โปรแกรมข้าม back-to-root ไม่เดินวน และแสดง partial อย่างตรงไปตรงมา |</a:t>
+              <a:t>| 00:00–00:25 | Scan แล้วเปิดบันทึกการทำงาน ดูจำนวนรายการ | Python เริ่ม process C รับข้อมูลผ่าน pipe และเว็บติดตามงานเบื้องหลัง |</a:t>
+            </a:r>
+          </a:p>
+          <a:p>
+            <a:r>
+              <a:t>| 00:25–00:50 | เข้า many เลือกอาคารหรือป้ายชื่อ ดูชื่อและขนาดที่ค้างอยู่ | ขนาดมาจาก metadata และ Windows API พื้นที่ฐานใช้เทียบขนาด |</a:t>
+            </a:r>
+          </a:p>
+          <a:p>
+            <a:r>
+              <a:t>| 00:50–01:15 | ค้น child-001 เลือกผลค้นหาแล้วเปิดตำแหน่ง | ค้นจากผลที่บันทึกใน SQLite ไม่เดินไฟล์ใหม่ ไม่จำกัดเฉพาะ 50 รายการที่โหลด |</a:t>
+            </a:r>
+          </a:p>
+          <a:p>
+            <a:r>
+              <a:t>| 01:15–01:35 | สลับรายการ โหลดเพิ่มจนเห็น 50+10 และเลือก zero.bin | เว็บขอข้อมูลทีละหน้า ศูนย์คือค่าที่วัดได้ ส่วน null คือไม่ทราบ |</a:t>
+            </a:r>
+          </a:p>
+          <a:p>
+            <a:r>
+              <a:t>| 01:35–02:00 | เปิดผล junction จริงที่เตรียมไว้ แล้วเปิดอ่านไม่ได้/ข้าม | ไม่ตามลิงก์เพื่อป้องกันการวน ผลบางส่วนมีเหตุผล ส่วนสิทธิ์จริงต้องให้ OS อนุญาต |</a:t>
             </a:r>
           </a:p>
           <a:p/>
           <a:p>
             <a:r>
-              <a:t>คำพูดปิดเดโม: เราเห็นทั้งการอ่านข้อมูลไฟล์ การส่งข้อมูลระหว่าง process และการจัดการรายการที่ไม่เดินต่อ โดยผลที่ไม่ครบจะมีเหตุผลให้ตรวจครับ</a:t>
+              <a:t>คำพูดปิด: เราเห็นการอ่าน metadata การส่งข้อมูลระหว่าง process และการแสดงพื้นที่จากข้อมูลที่ OS คืนให้ครับ</a:t>
             </a:r>
           </a:p>
           <a:p/>
           <a:p>
             <a:r>
-              <a:t>### เมื่อบันทึกเดโมมีปัญหา</a:t>
-            </a:r>
-          </a:p>
-          <a:p/>
-          <a:p>
-            <a:r>
-              <a:t>หากเริ่มสแกนไม่ได้ ให้แก้แล้วอัดช่วงนั้นใหม่ ไม่ใช้ mock แทนผลจริง หากผล junction ยังไม่ได้เตรียม ใช้ [ภาพเหตุผลจริง](results/real-web-issues.png) อธิบายเป็นภาพที่บันทึกไว้ได้ แต่ต้องบอกตรงว่าภาพไม่ใช่วิดีโอเดโม และหน้าเดโมยังรอไฟล์บันทึกหน้าจอจนกว่าจะอัดเสร็จ</a:t>
-            </a:r>
-          </a:p>
-          <a:p/>
-          <a:p>
-            <a:r>
-              <a:t>ไม่เริ่มสแกนทั้งไดรฟ์ใหม่ระหว่างเดโมหลัก การยกเลิกเป็นหัวข้อที่อธิบายจากผลทดสอบได้ หากมีเวลาและเตรียมงานจริงที่ยังทำอยู่จึงสาธิตเพิ่ม ห้ามใช้ผล cancelled เป็นผลทั้งไดรฟ์ที่สแกนจบแล้ว</a:t>
+              <a:t>วิดีโอเดโมและคลิปสุดท้ายยังต้องอัด ภาพหน้า 7 เป็นภาพนิ่งจากผลจริง ไม่ใช่วิดีโอที่เสร็จแล้ว หากมีปัญหาให้แก้และอัดใหม่ ไม่ใช้ข้อมูลทดลองแทน ไม่เริ่มสแกนทั้งไดรฟ์ระหว่างเดโมหลัก</a:t>
             </a:r>
           </a:p>
           <a:p/>
@@ -1179,7 +1172,7 @@
           <a:p/>
           <a:p>
             <a:r>
-              <a:t>หลักฐาน: docs/results/REAL_SCANNER_INTEGRATION.md; โค้ด: scanner/diskviz-scan.c, backend/scan_manager.py, backend/allocated_size.py</a:t>
+              <a:t>หลักฐาน: docs/results/UX_CITY_UAT.md; docs/results/READABLE_FILES_FIX.md; docs/results/REAL_SCANNER_INTEGRATION.md</a:t>
             </a:r>
           </a:p>
         </p:txBody>
@@ -1249,7 +1242,7 @@
           <a:lstStyle/>
           <a:p>
             <a:r>
-              <a:t>ผลที่แสดงขึ้นอยู่กับรายการที่ OS อนุญาตให้อ่านได้</a:t>
+              <a:t>ผลที่แสดงขึ้นอยู่กับข้อมูลที่อ่านได้</a:t>
             </a:r>
           </a:p>
           <a:p/>
@@ -1261,19 +1254,19 @@
           <a:p/>
           <a:p>
             <a:r>
-              <a:t>ชุดโฟลเดอร์จริงรับครบ 64 ไฟล์และ 13 โฟลเดอร์ แบ่งรายการ 50 กับ 10 ได้ รวมทั้งชื่อไทยและความลึก 8 ชั้นครับ กราฟผ่านการตรวจ browser 7 กรณี ชุด Python ผ่าน 23 ข้อและข้าม 12 ข้อ โดย C tests 11 ข้อในนั้นรันใน Ubuntu แยกผ่านแล้ว อีกหนึ่งข้อเป็นการสแกนทั้งไดรฟ์ที่ไม่ได้เลือกเปิดในรอบนี้</a:t>
+              <a:t>ชุดไฟล์จริงอ่านครบ 64 ไฟล์และ 13 โฟลเดอร์ รวมชื่อไทย ลึก 8 ชั้น และแบ่งลูก 60 รายการเป็น 50 กับ 10 ครับ เมืองและเว็บผ่าน 16 กรณี ชุด Python backend กับ search ล่าสุดผ่าน 20 ข้อ ส่วนชุด C จริงล่าสุดผ่าน 2 ข้อและข้าม 1 ข้อที่เป็นการสแกนทั้งไดรฟ์</a:t>
             </a:r>
           </a:p>
           <a:p/>
           <a:p>
             <a:r>
-              <a:t>ข้อจำกัดคือยอดรวมอ้างเฉพาะไฟล์ที่อ่านได้ เราตรวจสแกนไดรฟ์ D และยกเลิกสำเร็จ แต่ยังไม่ได้รอจนจบทั้งไดรฟ์ และไม่ได้ยืนยันทุกกรณีสิทธิ์ NTFS ครับ</a:t>
+              <a:t>ไฟล์บางรายการไม่มีสิทธิ์หรือถูกล็อก โปรแกรมแสดงเหตุผลและไม่ใส่ศูนย์แทนค่าที่ไม่ทราบ เราข้ามลิงก์เพื่อกันการวน และยังไม่ยืนยันครบทุกสิทธิ์ NTFS หรือผลสแกนทั้งไดรฟ์ที่จบสมบูรณ์ ยอดรวมไฟล์จึงอาจไม่เท่าพื้นที่ใช้ทั้งไดรฟ์ครับ</a:t>
             </a:r>
           </a:p>
           <a:p/>
           <a:p>
             <a:r>
-              <a:t>ไม่ต้องอ่านรายชื่อเทสต์ทั้งหมด หากถูกถามเรื่องสิทธิ์ ให้แยก C tests บน Linux ออกจากสิทธิ์ NTFS บน Windows</a:t>
+              <a:t>อ้าง [UX UAT](results/UX_CITY_UAT.md) และ [การแก้รับข้อมูล/metadata](results/READABLE_FILES_FIX.md) ตัวเลขมาจากชุดทดสอบคนละขอบเขต ไม่บวกเป็นจำนวน tests ทั้งระบบ ไม่อ้าง benchmark หรือแก้ต้นเหตุ C ส่งซ้ำสำเร็จแล้ว</a:t>
             </a:r>
           </a:p>
           <a:p/>
@@ -1281,7 +1274,7 @@
           <a:p/>
           <a:p>
             <a:r>
-              <a:t>หลักฐาน: docs/results/REAL_SCANNER_INTEGRATION.md; โค้ด: scanner/diskviz-scan.c, backend/scan_manager.py, backend/allocated_size.py</a:t>
+              <a:t>หลักฐาน: docs/results/UX_CITY_UAT.md; docs/results/READABLE_FILES_FIX.md; docs/results/REAL_SCANNER_INTEGRATION.md</a:t>
             </a:r>
           </a:p>
         </p:txBody>
@@ -1376,7 +1369,7 @@
           <a:p/>
           <a:p>
             <a:r>
-              <a:t>หลักฐาน: docs/results/REAL_SCANNER_INTEGRATION.md; โค้ด: scanner/diskviz-scan.c, backend/scan_manager.py, backend/allocated_size.py</a:t>
+              <a:t>หลักฐาน: docs/results/UX_CITY_UAT.md; docs/results/READABLE_FILES_FIX.md; docs/results/REAL_SCANNER_INTEGRATION.md</a:t>
             </a:r>
           </a:p>
         </p:txBody>
@@ -4743,26 +4736,7 @@
               </a:defRPr>
             </a:pPr>
             <a:r>
-              <a:t>โปรแกรมช่วยหาโฟลเดอร์</a:t>
-            </a:r>
-          </a:p>
-          <a:p>
-            <a:pPr>
-              <a:lnSpc>
-                <a:spcPct val="115000"/>
-              </a:lnSpc>
-              <a:spcAft>
-                <a:spcPts val="800"/>
-              </a:spcAft>
-              <a:defRPr sz="3600" b="1">
-                <a:solidFill>
-                  <a:srgbClr val="244966"/>
-                </a:solidFill>
-                <a:latin typeface="Sarabun"/>
-              </a:defRPr>
-            </a:pPr>
-            <a:r>
-              <a:t>ที่ใช้พื้นที่มาก</a:t>
+              <a:t>สำรวจพื้นที่ไฟล์เป็นเมือง</a:t>
             </a:r>
           </a:p>
         </p:txBody>
@@ -4818,7 +4792,7 @@
         <p:spPr>
           <a:xfrm>
             <a:off x="594360" y="1965960"/>
-            <a:ext cx="3840480" cy="2651760"/>
+            <a:ext cx="3840480" cy="2560320"/>
           </a:xfrm>
           <a:prstGeom prst="rect">
             <a:avLst/>
@@ -4846,7 +4820,7 @@
               </a:defRPr>
             </a:pPr>
             <a:r>
-              <a:t>กราฟแท่งเทียบขนาด</a:t>
+              <a:t>พื้นที่ฐานเทียบขนาดไฟล์</a:t>
             </a:r>
           </a:p>
           <a:p>
@@ -4865,7 +4839,7 @@
               </a:defRPr>
             </a:pPr>
             <a:r>
-              <a:t>สีเขียว: โฟลเดอร์</a:t>
+              <a:t>เลือกอาคาร ดูชื่อและขนาด</a:t>
             </a:r>
           </a:p>
           <a:p>
@@ -4884,54 +4858,11 @@
               </a:defRPr>
             </a:pPr>
             <a:r>
-              <a:t>สีน้ำเงิน: ไฟล์</a:t>
-            </a:r>
-          </a:p>
-          <a:p>
-            <a:pPr>
-              <a:lnSpc>
-                <a:spcPct val="115000"/>
-              </a:lnSpc>
-              <a:spcAft>
-                <a:spcPts val="800"/>
-              </a:spcAft>
-              <a:defRPr sz="2600" b="0">
-                <a:solidFill>
-                  <a:srgbClr val="1F2933"/>
-                </a:solidFill>
-                <a:latin typeface="Sarabun"/>
-              </a:defRPr>
-            </a:pPr>
-            <a:r>
-              <a:t>กดชื่อโฟลเดอร์เพื่อดูข้างใน</a:t>
-            </a:r>
-          </a:p>
-        </p:txBody>
-      </p:sp>
-      <p:pic>
-        <p:nvPicPr>
-          <p:cNvPr id="5" name="Picture 4" descr="size-bars-real-root.png"/>
-          <p:cNvPicPr>
-            <a:picLocks noChangeAspect="1"/>
-          </p:cNvPicPr>
-          <p:nvPr/>
-        </p:nvPicPr>
-        <p:blipFill>
-          <a:blip r:embed="rId3"/>
-          <a:stretch>
-            <a:fillRect/>
-          </a:stretch>
-        </p:blipFill>
-        <p:spPr>
-          <a:xfrm>
-            <a:off x="5158192" y="1874519"/>
-            <a:ext cx="5914215" cy="3794760"/>
-          </a:xfrm>
-          <a:prstGeom prst="rect">
-            <a:avLst/>
-          </a:prstGeom>
-        </p:spPr>
-      </p:pic>
+              <a:t>ค้นหาได้ทั้งผลสแกน</a:t>
+            </a:r>
+          </a:p>
+        </p:txBody>
+      </p:sp>
       <p:sp>
         <p:nvSpPr>
           <p:cNvPr id="6" name="TextBox 5"/>
@@ -4940,8 +4871,8 @@
         </p:nvSpPr>
         <p:spPr>
           <a:xfrm>
-            <a:off x="594360" y="5806440"/>
-            <a:ext cx="10972800" cy="457200"/>
+            <a:off x="594360" y="4800600"/>
+            <a:ext cx="3840480" cy="1463040"/>
           </a:xfrm>
           <a:prstGeom prst="rect">
             <a:avLst/>
@@ -4969,7 +4900,45 @@
               </a:defRPr>
             </a:pPr>
             <a:r>
-              <a:t>C ใน WSL → Python บน Windows → เว็บ</a:t>
+              <a:t>C ใน WSL</a:t>
+            </a:r>
+          </a:p>
+          <a:p>
+            <a:pPr>
+              <a:lnSpc>
+                <a:spcPct val="115000"/>
+              </a:lnSpc>
+              <a:spcAft>
+                <a:spcPts val="800"/>
+              </a:spcAft>
+              <a:defRPr sz="2600" b="1">
+                <a:solidFill>
+                  <a:srgbClr val="244966"/>
+                </a:solidFill>
+                <a:latin typeface="Sarabun"/>
+              </a:defRPr>
+            </a:pPr>
+            <a:r>
+              <a:t>↓ Python บน Windows</a:t>
+            </a:r>
+          </a:p>
+          <a:p>
+            <a:pPr>
+              <a:lnSpc>
+                <a:spcPct val="115000"/>
+              </a:lnSpc>
+              <a:spcAft>
+                <a:spcPts val="800"/>
+              </a:spcAft>
+              <a:defRPr sz="2600" b="1">
+                <a:solidFill>
+                  <a:srgbClr val="244966"/>
+                </a:solidFill>
+                <a:latin typeface="Sarabun"/>
+              </a:defRPr>
+            </a:pPr>
+            <a:r>
+              <a:t>↓ เว็บ</a:t>
             </a:r>
           </a:p>
         </p:txBody>
@@ -4982,8 +4951,8 @@
         </p:nvSpPr>
         <p:spPr>
           <a:xfrm>
-            <a:off x="4617720" y="1499616"/>
-            <a:ext cx="6995160" cy="320040"/>
+            <a:off x="5120640" y="1234440"/>
+            <a:ext cx="6400800" cy="320040"/>
           </a:xfrm>
           <a:prstGeom prst="rect">
             <a:avLst/>
@@ -5011,11 +4980,35 @@
               </a:defRPr>
             </a:pPr>
             <a:r>
-              <a:t>ภาพผลจริงจาก C และ Python บน Windows</a:t>
-            </a:r>
-          </a:p>
-        </p:txBody>
-      </p:sp>
+              <a:t>ภาพจากไฟล์โปรเจกต์จริง</a:t>
+            </a:r>
+          </a:p>
+        </p:txBody>
+      </p:sp>
+      <p:pic>
+        <p:nvPicPr>
+          <p:cNvPr id="8" name="Picture 7" descr="ux-project-city.png"/>
+          <p:cNvPicPr>
+            <a:picLocks noChangeAspect="1"/>
+          </p:cNvPicPr>
+          <p:nvPr/>
+        </p:nvPicPr>
+        <p:blipFill>
+          <a:blip r:embed="rId4"/>
+          <a:stretch>
+            <a:fillRect/>
+          </a:stretch>
+        </p:blipFill>
+        <p:spPr>
+          <a:xfrm>
+            <a:off x="5166360" y="1600200"/>
+            <a:ext cx="6400800" cy="4546991"/>
+          </a:xfrm>
+          <a:prstGeom prst="rect">
+            <a:avLst/>
+          </a:prstGeom>
+        </p:spPr>
+      </p:pic>
     </p:spTree>
   </p:cSld>
   <p:clrMapOvr>
@@ -7427,8 +7420,8 @@
         </p:nvSpPr>
         <p:spPr>
           <a:xfrm>
-            <a:off x="640080" y="1920240"/>
-            <a:ext cx="5029200" cy="3017520"/>
+            <a:off x="640080" y="1874519"/>
+            <a:ext cx="4892040" cy="3383280"/>
           </a:xfrm>
           <a:prstGeom prst="rect">
             <a:avLst/>
@@ -7456,7 +7449,7 @@
               </a:defRPr>
             </a:pPr>
             <a:r>
-              <a:t>01  Scan และดูสถานะ</a:t>
+              <a:t>01  Scan และดูบันทึกงาน</a:t>
             </a:r>
           </a:p>
           <a:p>
@@ -7475,7 +7468,7 @@
               </a:defRPr>
             </a:pPr>
             <a:r>
-              <a:t>02  ดูกราฟแท่งแล้วกดเข้าโฟลเดอร์</a:t>
+              <a:t>02  เลือกอาคาร ดูชื่อและขนาด</a:t>
             </a:r>
           </a:p>
           <a:p>
@@ -7494,7 +7487,7 @@
               </a:defRPr>
             </a:pPr>
             <a:r>
-              <a:t>03  กาง tree และแสดงเพิ่มเติม 50+10</a:t>
+              <a:t>03  ค้นหา แล้วเปิดตำแหน่ง</a:t>
             </a:r>
           </a:p>
           <a:p>
@@ -7513,35 +7506,30 @@
               </a:defRPr>
             </a:pPr>
             <a:r>
-              <a:t>04  ดูขนาด / Reveal / เหตุผลที่ข้าม</a:t>
-            </a:r>
-          </a:p>
-        </p:txBody>
-      </p:sp>
-      <p:pic>
-        <p:nvPicPr>
-          <p:cNvPr id="5" name="Picture 4" descr="size-bars-real-many.png"/>
-          <p:cNvPicPr>
-            <a:picLocks noChangeAspect="1"/>
-          </p:cNvPicPr>
-          <p:nvPr/>
-        </p:nvPicPr>
-        <p:blipFill>
-          <a:blip r:embed="rId3"/>
-          <a:stretch>
-            <a:fillRect/>
-          </a:stretch>
-        </p:blipFill>
-        <p:spPr>
-          <a:xfrm>
-            <a:off x="6982865" y="1920240"/>
-            <a:ext cx="3499308" cy="3291840"/>
-          </a:xfrm>
-          <a:prstGeom prst="rect">
-            <a:avLst/>
-          </a:prstGeom>
-        </p:spPr>
-      </p:pic>
+              <a:t>04  รายการเพิ่มเติม 50+10</a:t>
+            </a:r>
+          </a:p>
+          <a:p>
+            <a:pPr>
+              <a:lnSpc>
+                <a:spcPct val="115000"/>
+              </a:lnSpc>
+              <a:spcAft>
+                <a:spcPts val="800"/>
+              </a:spcAft>
+              <a:defRPr sz="2600" b="0">
+                <a:solidFill>
+                  <a:srgbClr val="1F2933"/>
+                </a:solidFill>
+                <a:latin typeface="Sarabun"/>
+              </a:defRPr>
+            </a:pPr>
+            <a:r>
+              <a:t>05  ดูเหตุผลที่อ่านไม่ได้</a:t>
+            </a:r>
+          </a:p>
+        </p:txBody>
+      </p:sp>
       <p:sp>
         <p:nvSpPr>
           <p:cNvPr id="6" name="TextBox 5"/>
@@ -7550,8 +7538,8 @@
         </p:nvSpPr>
         <p:spPr>
           <a:xfrm>
-            <a:off x="5897880" y="5303520"/>
-            <a:ext cx="5669280" cy="731520"/>
+            <a:off x="5806440" y="5596128"/>
+            <a:ext cx="5806440" cy="548640"/>
           </a:xfrm>
           <a:prstGeom prst="rect">
             <a:avLst/>
@@ -7579,26 +7567,7 @@
               </a:defRPr>
             </a:pPr>
             <a:r>
-              <a:t>ภาพจาก C จริง: กราฟไฟล์ใน many</a:t>
-            </a:r>
-          </a:p>
-          <a:p>
-            <a:pPr>
-              <a:lnSpc>
-                <a:spcPct val="115000"/>
-              </a:lnSpc>
-              <a:spcAft>
-                <a:spcPts val="800"/>
-              </a:spcAft>
-              <a:defRPr sz="2200" b="0">
-                <a:solidFill>
-                  <a:srgbClr val="526575"/>
-                </a:solidFill>
-                <a:latin typeface="Sarabun"/>
-              </a:defRPr>
-            </a:pPr>
-            <a:r>
-              <a:t>10 จาก 50 รายการที่โหลดแล้ว</a:t>
+              <a:t>เลือกไฟล์แล้วชื่อและขนาดค้างอยู่</a:t>
             </a:r>
           </a:p>
         </p:txBody>
@@ -7645,6 +7614,30 @@
           </a:p>
         </p:txBody>
       </p:sp>
+      <p:pic>
+        <p:nvPicPr>
+          <p:cNvPr id="8" name="Picture 7" descr="ux-small-file.png"/>
+          <p:cNvPicPr>
+            <a:picLocks noChangeAspect="1"/>
+          </p:cNvPicPr>
+          <p:nvPr/>
+        </p:nvPicPr>
+        <p:blipFill>
+          <a:blip r:embed="rId4"/>
+          <a:stretch>
+            <a:fillRect/>
+          </a:stretch>
+        </p:blipFill>
+        <p:spPr>
+          <a:xfrm>
+            <a:off x="5806440" y="1417320"/>
+            <a:ext cx="5806440" cy="3896748"/>
+          </a:xfrm>
+          <a:prstGeom prst="rect">
+            <a:avLst/>
+          </a:prstGeom>
+        </p:spPr>
+      </p:pic>
     </p:spTree>
   </p:cSld>
   <p:clrMapOvr>
@@ -7872,7 +7865,7 @@
               </a:defRPr>
             </a:pPr>
             <a:r>
-              <a:t>กราฟ/เบราว์เซอร์ 7 กรณีผ่าน</a:t>
+              <a:t>เมือง/เว็บ 16 กรณีผ่าน</a:t>
             </a:r>
           </a:p>
           <a:p>
@@ -7891,7 +7884,7 @@
               </a:defRPr>
             </a:pPr>
             <a:r>
-              <a:t>Python 23 ข้อผ่าน (12 ข้าม)</a:t>
+              <a:t>Python backend/search 20 ผ่าน</a:t>
             </a:r>
           </a:p>
           <a:p>
@@ -7910,7 +7903,7 @@
               </a:defRPr>
             </a:pPr>
             <a:r>
-              <a:t>C 11 ข้อผ่านใน Ubuntu</a:t>
+              <a:t>C จริงล่าสุด 2 ผ่าน / 1 ข้าม</a:t>
             </a:r>
           </a:p>
         </p:txBody>
@@ -7994,7 +7987,7 @@
               </a:defRPr>
             </a:pPr>
             <a:r>
-              <a:t>ยกเลิกไดรฟ์ D ได้</a:t>
+              <a:t>บางไฟล์ไม่มีสิทธิ์หรือถูกล็อก</a:t>
             </a:r>
           </a:p>
           <a:p>
@@ -8013,7 +8006,7 @@
               </a:defRPr>
             </a:pPr>
             <a:r>
-              <a:t>แต่ยังไม่ได้รอสแกนทั้งไดรฟ์จบ</a:t>
+              <a:t>ข้ามลิงก์เพื่อป้องกันการวน</a:t>
             </a:r>
           </a:p>
           <a:p>
@@ -8031,6 +8024,9 @@
                 <a:latin typeface="Sarabun"/>
               </a:defRPr>
             </a:pPr>
+            <a:r>
+              <a:t/>
+            </a:r>
           </a:p>
           <a:p>
             <a:pPr>
@@ -8048,7 +8044,7 @@
               </a:defRPr>
             </a:pPr>
             <a:r>
-              <a:t>ยังไม่ครอบคลุมทุกสิทธิ์ NTFS</a:t>
+              <a:t>ยังไม่ยืนยันครบทุกสิทธิ์ NTFS</a:t>
             </a:r>
           </a:p>
           <a:p>
@@ -8067,7 +8063,7 @@
               </a:defRPr>
             </a:pPr>
             <a:r>
-              <a:t>ยอดรวมไฟล์อาจไม่เท่าพื้นที่ใช้ไดรฟ์</a:t>
+              <a:t>ยอดไฟล์ไม่ใช่พื้นที่ใช้ทั้งไดรฟ์</a:t>
             </a:r>
           </a:p>
         </p:txBody>
@@ -8109,7 +8105,7 @@
               </a:defRPr>
             </a:pPr>
             <a:r>
-              <a:t>ผลบางส่วนต้องมีเหตุผล ไม่แทนค่าที่ไม่ทราบด้วยศูนย์</a:t>
+              <a:t>ผลบางส่วนแสดงเหตุผล · ขนาดที่ไม่ทราบเป็น null</a:t>
             </a:r>
           </a:p>
         </p:txBody>

</xml_diff>